<commit_message>
feat(powerbi): update review count by score
</commit_message>
<xml_diff>
--- a/Olist Report.pptx
+++ b/Olist Report.pptx
@@ -13669,7 +13669,7 @@
           <a:p>
             <a:fld id="{81651E38-EEA6-4DA6-A151-BCFF8201DA9A}" type="datetimeFigureOut">
               <a:rPr lang="en-US" smtClean="0"/>
-              <a:t>11/9/2025</a:t>
+              <a:t>11/10/2025</a:t>
             </a:fld>
             <a:endParaRPr lang="en-US"/>
           </a:p>
@@ -13920,7 +13920,7 @@
           <a:p>
             <a:fld id="{81651E38-EEA6-4DA6-A151-BCFF8201DA9A}" type="datetimeFigureOut">
               <a:rPr lang="en-US" smtClean="0"/>
-              <a:t>11/9/2025</a:t>
+              <a:t>11/10/2025</a:t>
             </a:fld>
             <a:endParaRPr lang="en-US"/>
           </a:p>
@@ -14234,7 +14234,7 @@
           <a:p>
             <a:fld id="{81651E38-EEA6-4DA6-A151-BCFF8201DA9A}" type="datetimeFigureOut">
               <a:rPr lang="en-US" smtClean="0"/>
-              <a:t>11/9/2025</a:t>
+              <a:t>11/10/2025</a:t>
             </a:fld>
             <a:endParaRPr lang="en-US"/>
           </a:p>
@@ -14575,7 +14575,7 @@
           <a:p>
             <a:fld id="{81651E38-EEA6-4DA6-A151-BCFF8201DA9A}" type="datetimeFigureOut">
               <a:rPr lang="en-US" smtClean="0"/>
-              <a:t>11/9/2025</a:t>
+              <a:t>11/10/2025</a:t>
             </a:fld>
             <a:endParaRPr lang="en-US"/>
           </a:p>
@@ -14889,7 +14889,7 @@
           <a:p>
             <a:fld id="{81651E38-EEA6-4DA6-A151-BCFF8201DA9A}" type="datetimeFigureOut">
               <a:rPr lang="en-US" smtClean="0"/>
-              <a:t>11/9/2025</a:t>
+              <a:t>11/10/2025</a:t>
             </a:fld>
             <a:endParaRPr lang="en-US"/>
           </a:p>
@@ -15282,7 +15282,7 @@
           <a:p>
             <a:fld id="{81651E38-EEA6-4DA6-A151-BCFF8201DA9A}" type="datetimeFigureOut">
               <a:rPr lang="en-US" smtClean="0"/>
-              <a:t>11/9/2025</a:t>
+              <a:t>11/10/2025</a:t>
             </a:fld>
             <a:endParaRPr lang="en-US"/>
           </a:p>
@@ -15452,7 +15452,7 @@
           <a:p>
             <a:fld id="{81651E38-EEA6-4DA6-A151-BCFF8201DA9A}" type="datetimeFigureOut">
               <a:rPr lang="en-US" smtClean="0"/>
-              <a:t>11/9/2025</a:t>
+              <a:t>11/10/2025</a:t>
             </a:fld>
             <a:endParaRPr lang="en-US"/>
           </a:p>
@@ -15632,7 +15632,7 @@
           <a:p>
             <a:fld id="{81651E38-EEA6-4DA6-A151-BCFF8201DA9A}" type="datetimeFigureOut">
               <a:rPr lang="en-US" smtClean="0"/>
-              <a:t>11/9/2025</a:t>
+              <a:t>11/10/2025</a:t>
             </a:fld>
             <a:endParaRPr lang="en-US"/>
           </a:p>
@@ -15808,7 +15808,7 @@
           <a:p>
             <a:fld id="{81651E38-EEA6-4DA6-A151-BCFF8201DA9A}" type="datetimeFigureOut">
               <a:rPr lang="en-US" smtClean="0"/>
-              <a:t>11/9/2025</a:t>
+              <a:t>11/10/2025</a:t>
             </a:fld>
             <a:endParaRPr lang="en-US"/>
           </a:p>
@@ -16055,7 +16055,7 @@
           <a:p>
             <a:fld id="{81651E38-EEA6-4DA6-A151-BCFF8201DA9A}" type="datetimeFigureOut">
               <a:rPr lang="en-US" smtClean="0"/>
-              <a:t>11/9/2025</a:t>
+              <a:t>11/10/2025</a:t>
             </a:fld>
             <a:endParaRPr lang="en-US"/>
           </a:p>
@@ -16287,7 +16287,7 @@
           <a:p>
             <a:fld id="{81651E38-EEA6-4DA6-A151-BCFF8201DA9A}" type="datetimeFigureOut">
               <a:rPr lang="en-US" smtClean="0"/>
-              <a:t>11/9/2025</a:t>
+              <a:t>11/10/2025</a:t>
             </a:fld>
             <a:endParaRPr lang="en-US"/>
           </a:p>
@@ -16661,7 +16661,7 @@
           <a:p>
             <a:fld id="{81651E38-EEA6-4DA6-A151-BCFF8201DA9A}" type="datetimeFigureOut">
               <a:rPr lang="en-US" smtClean="0"/>
-              <a:t>11/9/2025</a:t>
+              <a:t>11/10/2025</a:t>
             </a:fld>
             <a:endParaRPr lang="en-US"/>
           </a:p>
@@ -16784,7 +16784,7 @@
           <a:p>
             <a:fld id="{81651E38-EEA6-4DA6-A151-BCFF8201DA9A}" type="datetimeFigureOut">
               <a:rPr lang="en-US" smtClean="0"/>
-              <a:t>11/9/2025</a:t>
+              <a:t>11/10/2025</a:t>
             </a:fld>
             <a:endParaRPr lang="en-US"/>
           </a:p>
@@ -16879,7 +16879,7 @@
           <a:p>
             <a:fld id="{81651E38-EEA6-4DA6-A151-BCFF8201DA9A}" type="datetimeFigureOut">
               <a:rPr lang="en-US" smtClean="0"/>
-              <a:t>11/9/2025</a:t>
+              <a:t>11/10/2025</a:t>
             </a:fld>
             <a:endParaRPr lang="en-US"/>
           </a:p>
@@ -17134,7 +17134,7 @@
           <a:p>
             <a:fld id="{81651E38-EEA6-4DA6-A151-BCFF8201DA9A}" type="datetimeFigureOut">
               <a:rPr lang="en-US" smtClean="0"/>
-              <a:t>11/9/2025</a:t>
+              <a:t>11/10/2025</a:t>
             </a:fld>
             <a:endParaRPr lang="en-US"/>
           </a:p>
@@ -17397,7 +17397,7 @@
           <a:p>
             <a:fld id="{81651E38-EEA6-4DA6-A151-BCFF8201DA9A}" type="datetimeFigureOut">
               <a:rPr lang="en-US" smtClean="0"/>
-              <a:t>11/9/2025</a:t>
+              <a:t>11/10/2025</a:t>
             </a:fld>
             <a:endParaRPr lang="en-US"/>
           </a:p>
@@ -18140,7 +18140,7 @@
           <a:p>
             <a:fld id="{81651E38-EEA6-4DA6-A151-BCFF8201DA9A}" type="datetimeFigureOut">
               <a:rPr lang="en-US" smtClean="0"/>
-              <a:t>11/9/2025</a:t>
+              <a:t>11/10/2025</a:t>
             </a:fld>
             <a:endParaRPr lang="en-US"/>
           </a:p>
@@ -19194,36 +19194,6 @@
           </a:p>
         </p:txBody>
       </p:sp>
-      <p:pic>
-        <p:nvPicPr>
-          <p:cNvPr id="3" name="Picture 2"/>
-          <p:cNvPicPr>
-            <a:picLocks noChangeAspect="1"/>
-          </p:cNvPicPr>
-          <p:nvPr/>
-        </p:nvPicPr>
-        <p:blipFill>
-          <a:blip r:embed="rId2">
-            <a:extLst>
-              <a:ext uri="{28A0092B-C50C-407E-A947-70E740481C1C}">
-                <a14:useLocalDpi xmlns:a14="http://schemas.microsoft.com/office/drawing/2010/main" val="0"/>
-              </a:ext>
-            </a:extLst>
-          </a:blip>
-          <a:stretch>
-            <a:fillRect/>
-          </a:stretch>
-        </p:blipFill>
-        <p:spPr>
-          <a:xfrm>
-            <a:off x="4143375" y="710045"/>
-            <a:ext cx="7820024" cy="4305406"/>
-          </a:xfrm>
-          <a:prstGeom prst="rect">
-            <a:avLst/>
-          </a:prstGeom>
-        </p:spPr>
-      </p:pic>
       <p:sp>
         <p:nvSpPr>
           <p:cNvPr id="5" name="TextBox 4"/>
@@ -19398,6 +19368,36 @@
           </a:p>
         </p:txBody>
       </p:sp>
+      <p:pic>
+        <p:nvPicPr>
+          <p:cNvPr id="4" name="Picture 3"/>
+          <p:cNvPicPr>
+            <a:picLocks noChangeAspect="1"/>
+          </p:cNvPicPr>
+          <p:nvPr/>
+        </p:nvPicPr>
+        <p:blipFill>
+          <a:blip r:embed="rId2">
+            <a:extLst>
+              <a:ext uri="{28A0092B-C50C-407E-A947-70E740481C1C}">
+                <a14:useLocalDpi xmlns:a14="http://schemas.microsoft.com/office/drawing/2010/main" val="0"/>
+              </a:ext>
+            </a:extLst>
+          </a:blip>
+          <a:stretch>
+            <a:fillRect/>
+          </a:stretch>
+        </p:blipFill>
+        <p:spPr>
+          <a:xfrm>
+            <a:off x="4144253" y="361950"/>
+            <a:ext cx="7995889" cy="4435273"/>
+          </a:xfrm>
+          <a:prstGeom prst="rect">
+            <a:avLst/>
+          </a:prstGeom>
+        </p:spPr>
+      </p:pic>
     </p:spTree>
     <p:extLst>
       <p:ext uri="{BB962C8B-B14F-4D97-AF65-F5344CB8AC3E}">

</xml_diff>